<commit_message>
docs: bring the docs/ deliverables to v2.0, as built (T150)
The deliverables still described the August v1.0 plan: a four-person team over three releases,
an auto-remediation engine, Claude on classic Bedrock Agents, NL Q&A, a notification bell and
separate dev and prod accounts. Each is rewritten in place to the system as built, from clones of
its own styles so layout and branding are unchanged: the Capstone Overview (doc and deck, plus a
"Where It Stands" slide), the Architecture deck, the Plan & Tech Stack Guide (decisions as
built, components, security, AI, how it was delivered, how the risks played out), the
Engineering Guide (layout, 16 CI checks, deploy and teardown, the real connector contract,
runbooks from the live run), and the Backlog (each story's outcome and spec, plus an as-built
summary with live formulas). The original draft plan is unchanged; v1.0 stays in git history.

Co-Authored-By: Claude Opus 5.5 <noreply@anthropic.com>
</commit_message>
<xml_diff>
--- a/docs/CloudPulse-AI_Architecture.pptx
+++ b/docs/CloudPulse-AI_Architecture.pptx
@@ -1431,7 +1431,7 @@
                 <a:ea typeface="Arial" pitchFamily="34" charset="-122"/>
                 <a:cs typeface="Arial" pitchFamily="34" charset="-120"/>
               </a:rPr>
-              <a:t>Internal now, SaaS-ready  •  Python + FastAPI on Lambda  •  Angular 18  •  Amazon Bedrock  •  Aurora Serverless v2</a:t>
+              <a:t>Python + FastAPI on Lambda  •  Angular 18  •  Bedrock AgentCore + Nova 2 Lite  •  Aurora Serverless v2  •  Terraform</a:t>
             </a:r>
             <a:endParaRPr lang="en-US" sz="1300" dirty="0"/>
           </a:p>
@@ -1771,7 +1771,7 @@
                 <a:ea typeface="Arial" pitchFamily="34" charset="-122"/>
                 <a:cs typeface="Arial" pitchFamily="34" charset="-120"/>
               </a:rPr>
-              <a:t>Remediate</a:t>
+              <a:t>Explain</a:t>
             </a:r>
             <a:endParaRPr lang="en-US" sz="1200" dirty="0"/>
           </a:p>
@@ -1980,7 +1980,7 @@
                 <a:ea typeface="Arial" pitchFamily="34" charset="-122"/>
                 <a:cs typeface="Arial" pitchFamily="34" charset="-120"/>
               </a:rPr>
-              <a:t>v1.0 • August 2026 • All deliverables: Plan &amp; Tech Stack (docx), Backlog (xlsx), Engineering Guide (docx)</a:t>
+              <a:t>v2.0, as built • October 2026 • Companions: README, Plan &amp; Tech Stack (docx), Engineering Guide (docx), Backlog (xlsx)</a:t>
             </a:r>
             <a:endParaRPr lang="en-US" sz="1000" dirty="0"/>
           </a:p>
@@ -2090,7 +2090,7 @@
                 <a:ea typeface="Arial" pitchFamily="34" charset="-122"/>
                 <a:cs typeface="Arial" pitchFamily="34" charset="-120"/>
               </a:rPr>
-              <a:t>All CloudPulse components deploy in your hub AWS account; each spoke account gets one read-only IAM role via CloudFormation.</a:t>
+              <a:t>All CloudPulse components deploy in one AWS account; each added account gets one read-only IAM role via CloudFormation.</a:t>
             </a:r>
             <a:endParaRPr lang="en-US" sz="1200" dirty="0"/>
           </a:p>
@@ -2374,7 +2374,7 @@
                 <a:ea typeface="Arial" pitchFamily="34" charset="-122"/>
                 <a:cs typeface="Arial" pitchFamily="34" charset="-120"/>
               </a:rPr>
-              <a:t>CloudFront + WAF</a:t>
+              <a:t>CloudFront (OAC)</a:t>
             </a:r>
             <a:endParaRPr lang="en-US" sz="850" dirty="0"/>
           </a:p>
@@ -2526,7 +2526,7 @@
                 <a:ea typeface="Arial" pitchFamily="34" charset="-122"/>
                 <a:cs typeface="Arial" pitchFamily="34" charset="-120"/>
               </a:rPr>
-              <a:t>(SSO, JWT)</a:t>
+              <a:t>(3 role groups, JWT)</a:t>
             </a:r>
             <a:endParaRPr lang="en-US" sz="850" dirty="0"/>
           </a:p>
@@ -3306,7 +3306,7 @@
                 <a:ea typeface="Arial" pitchFamily="34" charset="-122"/>
                 <a:cs typeface="Arial" pitchFamily="34" charset="-120"/>
               </a:rPr>
-              <a:t>Scan Lambdas</a:t>
+              <a:t>Scan worker</a:t>
             </a:r>
             <a:endParaRPr lang="en-US" sz="850" dirty="0"/>
           </a:p>
@@ -3326,7 +3326,7 @@
                 <a:ea typeface="Arial" pitchFamily="34" charset="-122"/>
                 <a:cs typeface="Arial" pitchFamily="34" charset="-120"/>
               </a:rPr>
-              <a:t>(account × region × service)</a:t>
+              <a:t>(account × region)</a:t>
             </a:r>
             <a:endParaRPr lang="en-US" sz="850" dirty="0"/>
           </a:p>
@@ -3657,7 +3657,7 @@
                 <a:ea typeface="Arial" pitchFamily="34" charset="-122"/>
                 <a:cs typeface="Arial" pitchFamily="34" charset="-120"/>
               </a:rPr>
-              <a:t>Bedrock</a:t>
+              <a:t>AgentCore + Nova</a:t>
             </a:r>
             <a:endParaRPr lang="en-US" sz="800" dirty="0"/>
           </a:p>
@@ -3677,7 +3677,7 @@
                 <a:ea typeface="Arial" pitchFamily="34" charset="-122"/>
                 <a:cs typeface="Arial" pitchFamily="34" charset="-120"/>
               </a:rPr>
-              <a:t>insights (R2+)</a:t>
+              <a:t>digest, suggestions</a:t>
             </a:r>
             <a:endParaRPr lang="en-US" sz="800" dirty="0"/>
           </a:p>
@@ -4115,7 +4115,7 @@
                   <a:srgbClr val="5B6673"/>
                 </a:solidFill>
               </a:rPr>
-              <a:t>Launch: single account — CloudPulse deploys inside it; scan Lambdas use a local read-only role (no AssumeRole). Cross-account mode activates as accounts are added.</a:t>
+              <a:t>Same-account mode: CloudPulse scans the account it runs in with its own read-only roles. Cross-account mode activates as accounts are added.</a:t>
             </a:r>
             <a:endParaRPr lang="en-US" sz="750" dirty="0"/>
           </a:p>
@@ -4267,7 +4267,7 @@
                 <a:ea typeface="Arial" pitchFamily="34" charset="-122"/>
                 <a:cs typeface="Arial" pitchFamily="34" charset="-120"/>
               </a:rPr>
-              <a:t>CloudPulseScannerRole</a:t>
+              <a:t>cloudpulse-scanner</a:t>
             </a:r>
             <a:endParaRPr lang="en-US" sz="800" dirty="0"/>
           </a:p>
@@ -4987,7 +4987,7 @@
                 <a:ea typeface="Arial" pitchFamily="34" charset="-122"/>
                 <a:cs typeface="Arial" pitchFamily="34" charset="-120"/>
               </a:rPr>
-              <a:t>The core loop: discover → diff → validate → attribute → notify. Runs 02:00 IST daily plus on-demand from the UI.</a:t>
+              <a:t>The core loop: discover → diff → validate → attribute → notify. Runs 06:00 UTC daily plus on-demand from the UI.</a:t>
             </a:r>
             <a:endParaRPr lang="en-US" sz="1200" dirty="0"/>
           </a:p>
@@ -5375,7 +5375,7 @@
                   <a:srgbClr val="1A2433"/>
                 </a:solidFill>
               </a:rPr>
-              <a:t>Step Functions Map: one branch per (account × service group)</a:t>
+              <a:t>Step Functions: one unit of work per (account × region)</a:t>
             </a:r>
             <a:endParaRPr lang="en-US" sz="1050" dirty="0"/>
           </a:p>
@@ -5581,7 +5581,7 @@
                   <a:srgbClr val="1A2433"/>
                 </a:solidFill>
               </a:rPr>
-              <a:t>Scan Lambda assumes spoke role; Tagging API sweep + per-service enrichers</a:t>
+              <a:t>Scan worker uses its own role or assumes the scanner role; Tagging API + Cloud Control sweep, 10 enrichers</a:t>
             </a:r>
             <a:endParaRPr lang="en-US" sz="1050" dirty="0"/>
           </a:p>
@@ -5969,7 +5969,7 @@
                   <a:srgbClr val="1A2433"/>
                 </a:solidFill>
               </a:rPr>
-              <a:t>Upsert into Postgres; diff vs last scan opens/closes findings</a:t>
+              <a:t>Upsert + diff; SQS fan-out to compliance (findings, score) and ownership workers</a:t>
             </a:r>
             <a:endParaRPr lang="en-US" sz="1050" dirty="0"/>
           </a:p>
@@ -6175,7 +6175,7 @@
                   <a:srgbClr val="1A2433"/>
                 </a:solidFill>
               </a:rPr>
-              <a:t>Ownership worker mines CloudTrail: creator → frequent modifier → manual queue</a:t>
+              <a:t>Ownership worker reads CloudTrail write events: creator → fallback chain → unattributed</a:t>
             </a:r>
             <a:endParaRPr lang="en-US" sz="1050" dirty="0"/>
           </a:p>
@@ -6381,7 +6381,7 @@
                   <a:srgbClr val="1A2433"/>
                 </a:solidFill>
               </a:rPr>
-              <a:t>SES cadence day 0/2/4 + dashboard bell; unresolved after 4th interval → escalate</a:t>
+              <a:t>SES cadence day 0/2/4 (08:00 UTC); still open at day 4 → escalation flag</a:t>
             </a:r>
             <a:endParaRPr lang="en-US" sz="1050" dirty="0"/>
           </a:p>
@@ -6587,7 +6587,7 @@
                   <a:srgbClr val="1A2433"/>
                 </a:solidFill>
               </a:rPr>
-              <a:t>Scan history, durations, counts → History page; alarms on failures</a:t>
+              <a:t>Scan history, durations, added/changed/removed counts → Scan operations page</a:t>
             </a:r>
             <a:endParaRPr lang="en-US" sz="1050" dirty="0"/>
           </a:p>
@@ -6721,7 +6721,7 @@
                 <a:ea typeface="Arial" pitchFamily="34" charset="-122"/>
                 <a:cs typeface="Arial" pitchFamily="34" charset="-120"/>
               </a:rPr>
-              <a:t>Launch: same-account mode (local read-only role, no AssumeRole). Growth: deploy one CloudFormation stack per new account, register it with its scan-region list (default us-east-1). Access-key auth is deliberately not supported.</a:t>
+              <a:t>Same-account mode: CloudPulse scans its own account with its own read-only roles. Growth: deploy one CloudFormation stack per new account and register it with its scan regions. Access keys are deliberately not supported.</a:t>
             </a:r>
             <a:endParaRPr lang="en-US" sz="1200" dirty="0"/>
           </a:p>
@@ -6919,7 +6919,7 @@
                 <a:ea typeface="Arial" pitchFamily="34" charset="-122"/>
                 <a:cs typeface="Arial" pitchFamily="34" charset="-120"/>
               </a:rPr>
-              <a:t>Scan / remediation</a:t>
+              <a:t>Scan and worker</a:t>
             </a:r>
             <a:endParaRPr lang="en-US" sz="850" dirty="0"/>
           </a:p>
@@ -7025,7 +7025,7 @@
                 <a:ea typeface="Arial" pitchFamily="34" charset="-122"/>
                 <a:cs typeface="Arial" pitchFamily="34" charset="-120"/>
               </a:rPr>
-              <a:t>(scoped to CloudPulse* roles)</a:t>
+              <a:t>(scoped to cloudpulse-scanner)</a:t>
             </a:r>
             <a:endParaRPr lang="en-US" sz="850" dirty="0"/>
           </a:p>
@@ -7082,7 +7082,7 @@
                   <a:srgbClr val="1A2433"/>
                 </a:solidFill>
               </a:rPr>
-              <a:t>Per-tenant ExternalId (confused-deputy guard)</a:t>
+              <a:t>Platform-generated ExternalId per account (confused-deputy guard)</a:t>
             </a:r>
             <a:endParaRPr lang="en-US" sz="1100" dirty="0"/>
           </a:p>
@@ -7100,7 +7100,7 @@
                   <a:srgbClr val="1A2433"/>
                 </a:solidFill>
               </a:rPr>
-              <a:t>Read-only scanner: SecurityAudit + ViewOnlyAccess + tag:GetResources</a:t>
+              <a:t>Read-only scanner: an explicit Describe/Get/List list, checked by a unit test</a:t>
             </a:r>
             <a:endParaRPr lang="en-US" sz="1100" dirty="0"/>
           </a:p>
@@ -7118,7 +7118,7 @@
                   <a:srgbClr val="1A2433"/>
                 </a:solidFill>
               </a:rPr>
-              <a:t>Separate CloudPulseRemediatorRole (R2), tag-write only, opt-in per account</a:t>
+              <a:t>No write role exists: remediation is out of scope by design</a:t>
             </a:r>
             <a:endParaRPr lang="en-US" sz="1100" dirty="0"/>
           </a:p>
@@ -7136,7 +7136,7 @@
                   <a:srgbClr val="1A2433"/>
                 </a:solidFill>
               </a:rPr>
-              <a:t>Sessions 15 min, all calls in spoke CloudTrail</a:t>
+              <a:t>Sessions 15 min, all calls in the target account's CloudTrail</a:t>
             </a:r>
             <a:endParaRPr lang="en-US" sz="1100" dirty="0"/>
           </a:p>
@@ -7288,7 +7288,7 @@
                 <a:ea typeface="Arial" pitchFamily="34" charset="-122"/>
                 <a:cs typeface="Arial" pitchFamily="34" charset="-120"/>
               </a:rPr>
-              <a:t>Launch account — CloudPulse hub deploys INSIDE it</a:t>
+              <a:t>Same account — CloudPulse runs INSIDE it</a:t>
             </a:r>
             <a:endParaRPr lang="en-US" sz="1100" dirty="0"/>
           </a:p>
@@ -7348,7 +7348,7 @@
                   <a:srgbClr val="1A2433"/>
                 </a:solidFill>
               </a:rPr>
-              <a:t>Local read-only role (no AssumeRole)</a:t>
+              <a:t>Own read-only roles (no AssumeRole)</a:t>
             </a:r>
             <a:endParaRPr lang="en-US" sz="900" dirty="0"/>
           </a:p>
@@ -7546,7 +7546,7 @@
                   <a:srgbClr val="1A2433"/>
                 </a:solidFill>
               </a:rPr>
-              <a:t>CloudPulseScannerRole</a:t>
+              <a:t>cloudpulse-scanner</a:t>
             </a:r>
             <a:endParaRPr lang="en-US" sz="900" dirty="0"/>
           </a:p>
@@ -7744,7 +7744,7 @@
                   <a:srgbClr val="1A2433"/>
                 </a:solidFill>
               </a:rPr>
-              <a:t>CloudPulseScannerRole</a:t>
+              <a:t>cloudpulse-scanner</a:t>
             </a:r>
             <a:endParaRPr lang="en-US" sz="900" dirty="0"/>
           </a:p>
@@ -7923,7 +7923,7 @@
                 <a:ea typeface="Arial" pitchFamily="34" charset="-122"/>
                 <a:cs typeface="Arial" pitchFamily="34" charset="-120"/>
               </a:rPr>
-              <a:t>Cost Governance &amp; GenAI Layer (Release 2–3)</a:t>
+              <a:t>Cost Governance &amp; AI Layer</a:t>
             </a:r>
             <a:endParaRPr lang="en-US" sz="2600" dirty="0"/>
           </a:p>
@@ -7962,7 +7962,7 @@
                 <a:ea typeface="Arial" pitchFamily="34" charset="-122"/>
                 <a:cs typeface="Arial" pitchFamily="34" charset="-120"/>
               </a:rPr>
-              <a:t>Cost signals come from native AWS services; Bedrock explains and recommends — it never holds credentials or executes changes.</a:t>
+              <a:t>Cost signals come from native AWS services; the AI explains and recommends — it never holds credentials or executes changes.</a:t>
             </a:r>
             <a:endParaRPr lang="en-US" sz="1200" dirty="0"/>
           </a:p>
@@ -8089,7 +8089,7 @@
                 <a:ea typeface="Arial" pitchFamily="34" charset="-122"/>
                 <a:cs typeface="Arial" pitchFamily="34" charset="-120"/>
               </a:rPr>
-              <a:t>R2</a:t>
+              <a:t>P1/P2</a:t>
             </a:r>
             <a:endParaRPr lang="en-US" sz="900" dirty="0"/>
           </a:p>
@@ -8175,7 +8175,7 @@
                 <a:ea typeface="Arial" pitchFamily="34" charset="-122"/>
                 <a:cs typeface="Arial" pitchFamily="34" charset="-120"/>
               </a:rPr>
-              <a:t>spend by project tag</a:t>
+              <a:t>daily spend per account</a:t>
             </a:r>
             <a:endParaRPr lang="en-US" sz="850" dirty="0"/>
           </a:p>
@@ -8241,7 +8241,7 @@
                 <a:ea typeface="Arial" pitchFamily="34" charset="-122"/>
                 <a:cs typeface="Arial" pitchFamily="34" charset="-120"/>
               </a:rPr>
-              <a:t>AWS Budgets</a:t>
+              <a:t>Budgets per SDA</a:t>
             </a:r>
             <a:endParaRPr lang="en-US" sz="850" dirty="0"/>
           </a:p>
@@ -8261,7 +8261,7 @@
                 <a:ea typeface="Arial" pitchFamily="34" charset="-122"/>
                 <a:cs typeface="Arial" pitchFamily="34" charset="-120"/>
               </a:rPr>
-              <a:t>auto-created per project</a:t>
+              <a:t>auto-created in CloudPulse</a:t>
             </a:r>
             <a:endParaRPr lang="en-US" sz="850" dirty="0"/>
           </a:p>
@@ -8281,7 +8281,7 @@
                 <a:ea typeface="Arial" pitchFamily="34" charset="-122"/>
                 <a:cs typeface="Arial" pitchFamily="34" charset="-120"/>
               </a:rPr>
-              <a:t>80% / 100% alerts</a:t>
+              <a:t>overrun → finding</a:t>
             </a:r>
             <a:endParaRPr lang="en-US" sz="850" dirty="0"/>
           </a:p>
@@ -8347,7 +8347,7 @@
                 <a:ea typeface="Arial" pitchFamily="34" charset="-122"/>
                 <a:cs typeface="Arial" pitchFamily="34" charset="-120"/>
               </a:rPr>
-              <a:t>Compute Optimizer</a:t>
+              <a:t>CloudWatch metrics</a:t>
             </a:r>
             <a:endParaRPr lang="en-US" sz="850" dirty="0"/>
           </a:p>
@@ -8367,7 +8367,7 @@
                 <a:ea typeface="Arial" pitchFamily="34" charset="-122"/>
                 <a:cs typeface="Arial" pitchFamily="34" charset="-120"/>
               </a:rPr>
-              <a:t>rightsizing signals</a:t>
+              <a:t>rightsizing evidence</a:t>
             </a:r>
             <a:endParaRPr lang="en-US" sz="850" dirty="0"/>
           </a:p>
@@ -8410,7 +8410,7 @@
                   <a:srgbClr val="1A2433"/>
                 </a:solidFill>
               </a:rPr>
-              <a:t>Overrun detection: forecast + actual vs project budget → findings pipeline (same lifecycle as tag findings)</a:t>
+              <a:t>Overrun detection: actual spend vs SDA budget → findings pipeline (same lifecycle as tag findings)</a:t>
             </a:r>
             <a:endParaRPr lang="en-US" sz="1100" dirty="0"/>
           </a:p>
@@ -8431,7 +8431,7 @@
                   <a:srgbClr val="1A2433"/>
                 </a:solidFill>
               </a:rPr>
-              <a:t>Unused resources: idle EC2, unattached EBS, orphaned EIPs, idle RDS → savings estimates</a:t>
+              <a:t>Utilization: active vs idle from resource state; IAM hygiene flags unused principals weekly</a:t>
             </a:r>
             <a:endParaRPr lang="en-US" sz="1100" dirty="0"/>
           </a:p>
@@ -8452,7 +8452,7 @@
                   <a:srgbClr val="1A2433"/>
                 </a:solidFill>
               </a:rPr>
-              <a:t>Cost dashboard: spend by project / SDA / environment with drill-down; sandbox utilization % (R3)</a:t>
+              <a:t>Cost dashboard: daily spend by account and SDA; forecasts with their backtest error</a:t>
             </a:r>
             <a:endParaRPr lang="en-US" sz="1100" dirty="0"/>
           </a:p>
@@ -8473,7 +8473,7 @@
                   <a:srgbClr val="1A2433"/>
                 </a:solidFill>
               </a:rPr>
-              <a:t>Recommendations: shutdown, cleanup, rightsize (m5.2xlarge → m5.xlarge), reserved capacity</a:t>
+              <a:t>Rightsizing: low and steady CPU → one size down, with evidence and an estimated saving</a:t>
             </a:r>
             <a:endParaRPr lang="en-US" sz="1100" dirty="0"/>
           </a:p>
@@ -8539,7 +8539,7 @@
                 <a:ea typeface="Arial" pitchFamily="34" charset="-122"/>
                 <a:cs typeface="Arial" pitchFamily="34" charset="-120"/>
               </a:rPr>
-              <a:t>GenAI on Amazon Bedrock (Claude)</a:t>
+              <a:t>AI on Bedrock AgentCore + Nova 2 Lite</a:t>
             </a:r>
             <a:endParaRPr lang="en-US" sz="1100" dirty="0"/>
           </a:p>
@@ -8600,7 +8600,7 @@
                 <a:ea typeface="Arial" pitchFamily="34" charset="-122"/>
                 <a:cs typeface="Arial" pitchFamily="34" charset="-120"/>
               </a:rPr>
-              <a:t>R2+</a:t>
+              <a:t>P1/P2</a:t>
             </a:r>
             <a:endParaRPr lang="en-US" sz="900" dirty="0"/>
           </a:p>
@@ -8666,7 +8666,7 @@
                 <a:ea typeface="Arial" pitchFamily="34" charset="-122"/>
                 <a:cs typeface="Arial" pitchFamily="34" charset="-120"/>
               </a:rPr>
-              <a:t>Bedrock</a:t>
+              <a:t>AgentCore Runtime</a:t>
             </a:r>
             <a:endParaRPr lang="en-US" sz="850" dirty="0"/>
           </a:p>
@@ -8686,7 +8686,7 @@
                 <a:ea typeface="Arial" pitchFamily="34" charset="-122"/>
                 <a:cs typeface="Arial" pitchFamily="34" charset="-120"/>
               </a:rPr>
-              <a:t>Converse API</a:t>
+              <a:t>Converse tool loop</a:t>
             </a:r>
             <a:endParaRPr lang="en-US" sz="850" dirty="0"/>
           </a:p>
@@ -8752,7 +8752,7 @@
                 <a:ea typeface="Arial" pitchFamily="34" charset="-122"/>
                 <a:cs typeface="Arial" pitchFamily="34" charset="-120"/>
               </a:rPr>
-              <a:t>Insight jobs</a:t>
+              <a:t>Daily workers</a:t>
             </a:r>
             <a:endParaRPr lang="en-US" sz="850" dirty="0"/>
           </a:p>
@@ -8772,7 +8772,7 @@
                 <a:ea typeface="Arial" pitchFamily="34" charset="-122"/>
                 <a:cs typeface="Arial" pitchFamily="34" charset="-120"/>
               </a:rPr>
-              <a:t>(nightly digest)</a:t>
+              <a:t>(digest, suggester)</a:t>
             </a:r>
             <a:endParaRPr lang="en-US" sz="850" dirty="0"/>
           </a:p>
@@ -8858,7 +8858,7 @@
                 <a:ea typeface="Arial" pitchFamily="34" charset="-122"/>
                 <a:cs typeface="Arial" pitchFamily="34" charset="-120"/>
               </a:rPr>
-              <a:t>for NL Q&amp;A (R3)</a:t>
+              <a:t>allowlisted GETs only</a:t>
             </a:r>
             <a:endParaRPr lang="en-US" sz="850" dirty="0"/>
           </a:p>
@@ -8901,7 +8901,7 @@
                   <a:srgbClr val="1A2433"/>
                 </a:solidFill>
               </a:rPr>
-              <a:t>Findings digest: nightly summary of top findings + cost deltas → dashboard card + weekly email</a:t>
+              <a:t>Insight digest: daily summary of top findings + spend → overview card, grounded before display</a:t>
             </a:r>
             <a:endParaRPr lang="en-US" sz="1100" dirty="0"/>
           </a:p>
@@ -8922,7 +8922,7 @@
                   <a:srgbClr val="1A2433"/>
                 </a:solidFill>
               </a:rPr>
-              <a:t>Remediation suggester: drafts action + blast-radius note per finding class; human approves</a:t>
+              <a:t>Remediation suggester: one suggestion + blast-radius note per finding; people act on it</a:t>
             </a:r>
             <a:endParaRPr lang="en-US" sz="1100" dirty="0"/>
           </a:p>
@@ -8943,7 +8943,7 @@
                   <a:srgbClr val="1A2433"/>
                 </a:solidFill>
               </a:rPr>
-              <a:t>NL Q&amp;A (R3): “Which untagged prod resources cost most last month?” — tool-use against CloudPulse API, tenant-scoped, answers cite ARNs</a:t>
+              <a:t>Grounding gate: deterministic code rejects any invented ARN or figure; rejections are recorded, never shown</a:t>
             </a:r>
             <a:endParaRPr lang="en-US" sz="1100" dirty="0"/>
           </a:p>
@@ -8964,7 +8964,7 @@
                   <a:srgbClr val="1A2433"/>
                 </a:solidFill>
               </a:rPr>
-              <a:t>Cost control: Haiku for classification, Sonnet for digests; cached outputs; Bedrock budget alarm</a:t>
+              <a:t>Cost control: per-run token cap; item-wise outputs keep validated items; Guardrail on every call</a:t>
             </a:r>
             <a:endParaRPr lang="en-US" sz="1100" dirty="0"/>
           </a:p>
@@ -9074,7 +9074,7 @@
                 <a:ea typeface="Arial" pitchFamily="34" charset="-122"/>
                 <a:cs typeface="Arial" pitchFamily="34" charset="-120"/>
               </a:rPr>
-              <a:t>Monorepo: /infra (Terraform), /backend (FastAPI + workers), /frontend (Angular), /connectors. Trunk-based; deploy on merge to main.</a:t>
+              <a:t>Monorepo: /infra (Terraform), /backend (FastAPI + workers), /frontend (Angular), /agents, /specs. Trunk-based on pods/pod73.</a:t>
             </a:r>
             <a:endParaRPr lang="en-US" sz="1200" dirty="0"/>
           </a:p>
@@ -9137,7 +9137,7 @@
                   <a:srgbClr val="232F3E"/>
                 </a:solidFill>
               </a:rPr>
-              <a:t>Push / PR</a:t>
+              <a:t>Pull request</a:t>
             </a:r>
             <a:endParaRPr lang="en-US" sz="1300" dirty="0"/>
           </a:p>
@@ -9176,7 +9176,7 @@
                   <a:srgbClr val="1A2433"/>
                 </a:solidFill>
               </a:rPr>
-              <a:t>Lint • mypy • unit tests (moto) • Angular build • tf validate &amp; plan</a:t>
+              <a:t>16 required checks: lint • types • unit • integration • e2e • tf • contract • evals • AI review</a:t>
             </a:r>
             <a:endParaRPr lang="en-US" sz="1000" dirty="0"/>
           </a:p>
@@ -9263,7 +9263,7 @@
                   <a:srgbClr val="232F3E"/>
                 </a:solidFill>
               </a:rPr>
-              <a:t>Merge to main</a:t>
+              <a:t>Merge to pods/pod73</a:t>
             </a:r>
             <a:endParaRPr lang="en-US" sz="1300" dirty="0"/>
           </a:p>
@@ -9302,7 +9302,7 @@
                   <a:srgbClr val="1A2433"/>
                 </a:solidFill>
               </a:rPr>
-              <a:t>Integration tests (LocalStack) • package Lambdas • build SPA</a:t>
+              <a:t>Trunk stays green; automatic dev deploy is off (DEV_AUTO_DEPLOY=false)</a:t>
             </a:r>
             <a:endParaRPr lang="en-US" sz="1000" dirty="0"/>
           </a:p>
@@ -9389,7 +9389,7 @@
                   <a:srgbClr val="232F3E"/>
                 </a:solidFill>
               </a:rPr>
-              <a:t>Deploy dev</a:t>
+              <a:t>Deploy dev (manual)</a:t>
             </a:r>
             <a:endParaRPr lang="en-US" sz="1300" dirty="0"/>
           </a:p>
@@ -9428,7 +9428,7 @@
                   <a:srgbClr val="1A2433"/>
                 </a:solidFill>
               </a:rPr>
-              <a:t>terraform apply (auto) • Alembic migrations • smoke tests</a:t>
+              <a:t>build • terraform apply (optional NAT egress) • migrations • health + Playwright smoke</a:t>
             </a:r>
             <a:endParaRPr lang="en-US" sz="1000" dirty="0"/>
           </a:p>
@@ -9515,7 +9515,7 @@
                   <a:srgbClr val="232F3E"/>
                 </a:solidFill>
               </a:rPr>
-              <a:t>Deploy prod</a:t>
+              <a:t>Teardown</a:t>
             </a:r>
             <a:endParaRPr lang="en-US" sz="1300" dirty="0"/>
           </a:p>
@@ -9554,7 +9554,7 @@
                   <a:srgbClr val="1A2433"/>
                 </a:solidFill>
               </a:rPr>
-              <a:t>Manual approval gate • apply • CloudFront invalidation • canary alarm watch</a:t>
+              <a:t>ops/teardown.sh dev • sweep against the pre-deploy baseline • zero cost</a:t>
             </a:r>
             <a:endParaRPr lang="en-US" sz="1000" dirty="0"/>
           </a:p>
@@ -9620,7 +9620,7 @@
                 <a:ea typeface="Arial" pitchFamily="34" charset="-122"/>
                 <a:cs typeface="Arial" pitchFamily="34" charset="-120"/>
               </a:rPr>
-              <a:t>dev environment (hub account: cloudpulse-dev)</a:t>
+              <a:t>dev — the one environment, deployed per working session</a:t>
             </a:r>
             <a:endParaRPr lang="en-US" sz="1100" dirty="0"/>
           </a:p>
@@ -9686,7 +9686,7 @@
                 <a:ea typeface="Arial" pitchFamily="34" charset="-122"/>
                 <a:cs typeface="Arial" pitchFamily="34" charset="-120"/>
               </a:rPr>
-              <a:t>prod environment (hub account: cloudpulse-prod)</a:t>
+              <a:t>prod root module — kept in the repo, unused by decision</a:t>
             </a:r>
             <a:endParaRPr lang="en-US" sz="1100" dirty="0"/>
           </a:p>
@@ -10086,7 +10086,7 @@
                   <a:srgbClr val="1A2433"/>
                 </a:solidFill>
               </a:rPr>
-              <a:t>Separate hub accounts for dev and prod; spokes onboard to prod only</a:t>
+              <a:t>One environment by decision: dev is deployed for a session, then torn down</a:t>
             </a:r>
             <a:endParaRPr lang="en-US" sz="1050" dirty="0"/>
           </a:p>
@@ -10104,7 +10104,7 @@
                   <a:srgbClr val="1A2433"/>
                 </a:solidFill>
               </a:rPr>
-              <a:t>GitHub OIDC federation → short-lived deploy roles per environment</a:t>
+              <a:t>GitHub OIDC federation → short-lived deploy role, no stored keys</a:t>
             </a:r>
             <a:endParaRPr lang="en-US" sz="1050" dirty="0"/>
           </a:p>
@@ -10122,7 +10122,7 @@
                   <a:srgbClr val="1A2433"/>
                 </a:solidFill>
               </a:rPr>
-              <a:t>Terraform state in S3 + DynamoDB lock, one state per env</a:t>
+              <a:t>Terraform state in S3 + DynamoDB lock</a:t>
             </a:r>
             <a:endParaRPr lang="en-US" sz="1050" dirty="0"/>
           </a:p>
@@ -10162,7 +10162,7 @@
                   <a:srgbClr val="1A2433"/>
                 </a:solidFill>
               </a:rPr>
-              <a:t>Rollback: Lambda aliases + previous artifact re-deploy; DB via expand-contract migrations</a:t>
+              <a:t>Rollback: redeploy the previous commit; migrations are additive-only</a:t>
             </a:r>
             <a:endParaRPr lang="en-US" sz="1050" dirty="0"/>
           </a:p>
@@ -10180,7 +10180,7 @@
                   <a:srgbClr val="1A2433"/>
                 </a:solidFill>
               </a:rPr>
-              <a:t>Observability: CloudWatch dashboards + alarms → SNS → email/Slack</a:t>
+              <a:t>Observability: structured logs + correlation IDs; dashboards and alarms are optional (P2, off)</a:t>
             </a:r>
             <a:endParaRPr lang="en-US" sz="1050" dirty="0"/>
           </a:p>
@@ -10198,7 +10198,7 @@
                   <a:srgbClr val="1A2433"/>
                 </a:solidFill>
               </a:rPr>
-              <a:t>Full pipeline YAML and runbooks in the Engineering Guide (docx)</a:t>
+              <a:t>Full pipeline, provisioning and teardown in the Engineering Guide and README</a:t>
             </a:r>
             <a:endParaRPr lang="en-US" sz="1050" dirty="0"/>
           </a:p>

</xml_diff>

<commit_message>
docs: bring the docs/ deliverables to v2.0, as built (T150) (#165)
The deliverables still described the August v1.0 plan: a four-person team over three releases,
an auto-remediation engine, Claude on classic Bedrock Agents, NL Q&A, a notification bell and
separate dev and prod accounts. Each is rewritten in place to the system as built, from clones of
its own styles so layout and branding are unchanged: the Capstone Overview (doc and deck, plus a
"Where It Stands" slide), the Architecture deck, the Plan & Tech Stack Guide (decisions as
built, components, security, AI, how it was delivered, how the risks played out), the
Engineering Guide (layout, 16 CI checks, deploy and teardown, the real connector contract,
runbooks from the live run), and the Backlog (each story's outcome and spec, plus an as-built
summary with live formulas). The original draft plan is unchanged; v1.0 stays in git history.

Co-authored-by: Claude Opus 5.5 <noreply@anthropic.com>
</commit_message>
<xml_diff>
--- a/docs/CloudPulse-AI_Architecture.pptx
+++ b/docs/CloudPulse-AI_Architecture.pptx
@@ -1431,7 +1431,7 @@
                 <a:ea typeface="Arial" pitchFamily="34" charset="-122"/>
                 <a:cs typeface="Arial" pitchFamily="34" charset="-120"/>
               </a:rPr>
-              <a:t>Internal now, SaaS-ready  •  Python + FastAPI on Lambda  •  Angular 18  •  Amazon Bedrock  •  Aurora Serverless v2</a:t>
+              <a:t>Python + FastAPI on Lambda  •  Angular 18  •  Bedrock AgentCore + Nova 2 Lite  •  Aurora Serverless v2  •  Terraform</a:t>
             </a:r>
             <a:endParaRPr lang="en-US" sz="1300" dirty="0"/>
           </a:p>
@@ -1771,7 +1771,7 @@
                 <a:ea typeface="Arial" pitchFamily="34" charset="-122"/>
                 <a:cs typeface="Arial" pitchFamily="34" charset="-120"/>
               </a:rPr>
-              <a:t>Remediate</a:t>
+              <a:t>Explain</a:t>
             </a:r>
             <a:endParaRPr lang="en-US" sz="1200" dirty="0"/>
           </a:p>
@@ -1980,7 +1980,7 @@
                 <a:ea typeface="Arial" pitchFamily="34" charset="-122"/>
                 <a:cs typeface="Arial" pitchFamily="34" charset="-120"/>
               </a:rPr>
-              <a:t>v1.0 • August 2026 • All deliverables: Plan &amp; Tech Stack (docx), Backlog (xlsx), Engineering Guide (docx)</a:t>
+              <a:t>v2.0, as built • October 2026 • Companions: README, Plan &amp; Tech Stack (docx), Engineering Guide (docx), Backlog (xlsx)</a:t>
             </a:r>
             <a:endParaRPr lang="en-US" sz="1000" dirty="0"/>
           </a:p>
@@ -2090,7 +2090,7 @@
                 <a:ea typeface="Arial" pitchFamily="34" charset="-122"/>
                 <a:cs typeface="Arial" pitchFamily="34" charset="-120"/>
               </a:rPr>
-              <a:t>All CloudPulse components deploy in your hub AWS account; each spoke account gets one read-only IAM role via CloudFormation.</a:t>
+              <a:t>All CloudPulse components deploy in one AWS account; each added account gets one read-only IAM role via CloudFormation.</a:t>
             </a:r>
             <a:endParaRPr lang="en-US" sz="1200" dirty="0"/>
           </a:p>
@@ -2374,7 +2374,7 @@
                 <a:ea typeface="Arial" pitchFamily="34" charset="-122"/>
                 <a:cs typeface="Arial" pitchFamily="34" charset="-120"/>
               </a:rPr>
-              <a:t>CloudFront + WAF</a:t>
+              <a:t>CloudFront (OAC)</a:t>
             </a:r>
             <a:endParaRPr lang="en-US" sz="850" dirty="0"/>
           </a:p>
@@ -2526,7 +2526,7 @@
                 <a:ea typeface="Arial" pitchFamily="34" charset="-122"/>
                 <a:cs typeface="Arial" pitchFamily="34" charset="-120"/>
               </a:rPr>
-              <a:t>(SSO, JWT)</a:t>
+              <a:t>(3 role groups, JWT)</a:t>
             </a:r>
             <a:endParaRPr lang="en-US" sz="850" dirty="0"/>
           </a:p>
@@ -3306,7 +3306,7 @@
                 <a:ea typeface="Arial" pitchFamily="34" charset="-122"/>
                 <a:cs typeface="Arial" pitchFamily="34" charset="-120"/>
               </a:rPr>
-              <a:t>Scan Lambdas</a:t>
+              <a:t>Scan worker</a:t>
             </a:r>
             <a:endParaRPr lang="en-US" sz="850" dirty="0"/>
           </a:p>
@@ -3326,7 +3326,7 @@
                 <a:ea typeface="Arial" pitchFamily="34" charset="-122"/>
                 <a:cs typeface="Arial" pitchFamily="34" charset="-120"/>
               </a:rPr>
-              <a:t>(account × region × service)</a:t>
+              <a:t>(account × region)</a:t>
             </a:r>
             <a:endParaRPr lang="en-US" sz="850" dirty="0"/>
           </a:p>
@@ -3657,7 +3657,7 @@
                 <a:ea typeface="Arial" pitchFamily="34" charset="-122"/>
                 <a:cs typeface="Arial" pitchFamily="34" charset="-120"/>
               </a:rPr>
-              <a:t>Bedrock</a:t>
+              <a:t>AgentCore + Nova</a:t>
             </a:r>
             <a:endParaRPr lang="en-US" sz="800" dirty="0"/>
           </a:p>
@@ -3677,7 +3677,7 @@
                 <a:ea typeface="Arial" pitchFamily="34" charset="-122"/>
                 <a:cs typeface="Arial" pitchFamily="34" charset="-120"/>
               </a:rPr>
-              <a:t>insights (R2+)</a:t>
+              <a:t>digest, suggestions</a:t>
             </a:r>
             <a:endParaRPr lang="en-US" sz="800" dirty="0"/>
           </a:p>
@@ -4115,7 +4115,7 @@
                   <a:srgbClr val="5B6673"/>
                 </a:solidFill>
               </a:rPr>
-              <a:t>Launch: single account — CloudPulse deploys inside it; scan Lambdas use a local read-only role (no AssumeRole). Cross-account mode activates as accounts are added.</a:t>
+              <a:t>Same-account mode: CloudPulse scans the account it runs in with its own read-only roles. Cross-account mode activates as accounts are added.</a:t>
             </a:r>
             <a:endParaRPr lang="en-US" sz="750" dirty="0"/>
           </a:p>
@@ -4267,7 +4267,7 @@
                 <a:ea typeface="Arial" pitchFamily="34" charset="-122"/>
                 <a:cs typeface="Arial" pitchFamily="34" charset="-120"/>
               </a:rPr>
-              <a:t>CloudPulseScannerRole</a:t>
+              <a:t>cloudpulse-scanner</a:t>
             </a:r>
             <a:endParaRPr lang="en-US" sz="800" dirty="0"/>
           </a:p>
@@ -4987,7 +4987,7 @@
                 <a:ea typeface="Arial" pitchFamily="34" charset="-122"/>
                 <a:cs typeface="Arial" pitchFamily="34" charset="-120"/>
               </a:rPr>
-              <a:t>The core loop: discover → diff → validate → attribute → notify. Runs 02:00 IST daily plus on-demand from the UI.</a:t>
+              <a:t>The core loop: discover → diff → validate → attribute → notify. Runs 06:00 UTC daily plus on-demand from the UI.</a:t>
             </a:r>
             <a:endParaRPr lang="en-US" sz="1200" dirty="0"/>
           </a:p>
@@ -5375,7 +5375,7 @@
                   <a:srgbClr val="1A2433"/>
                 </a:solidFill>
               </a:rPr>
-              <a:t>Step Functions Map: one branch per (account × service group)</a:t>
+              <a:t>Step Functions: one unit of work per (account × region)</a:t>
             </a:r>
             <a:endParaRPr lang="en-US" sz="1050" dirty="0"/>
           </a:p>
@@ -5581,7 +5581,7 @@
                   <a:srgbClr val="1A2433"/>
                 </a:solidFill>
               </a:rPr>
-              <a:t>Scan Lambda assumes spoke role; Tagging API sweep + per-service enrichers</a:t>
+              <a:t>Scan worker uses its own role or assumes the scanner role; Tagging API + Cloud Control sweep, 10 enrichers</a:t>
             </a:r>
             <a:endParaRPr lang="en-US" sz="1050" dirty="0"/>
           </a:p>
@@ -5969,7 +5969,7 @@
                   <a:srgbClr val="1A2433"/>
                 </a:solidFill>
               </a:rPr>
-              <a:t>Upsert into Postgres; diff vs last scan opens/closes findings</a:t>
+              <a:t>Upsert + diff; SQS fan-out to compliance (findings, score) and ownership workers</a:t>
             </a:r>
             <a:endParaRPr lang="en-US" sz="1050" dirty="0"/>
           </a:p>
@@ -6175,7 +6175,7 @@
                   <a:srgbClr val="1A2433"/>
                 </a:solidFill>
               </a:rPr>
-              <a:t>Ownership worker mines CloudTrail: creator → frequent modifier → manual queue</a:t>
+              <a:t>Ownership worker reads CloudTrail write events: creator → fallback chain → unattributed</a:t>
             </a:r>
             <a:endParaRPr lang="en-US" sz="1050" dirty="0"/>
           </a:p>
@@ -6381,7 +6381,7 @@
                   <a:srgbClr val="1A2433"/>
                 </a:solidFill>
               </a:rPr>
-              <a:t>SES cadence day 0/2/4 + dashboard bell; unresolved after 4th interval → escalate</a:t>
+              <a:t>SES cadence day 0/2/4 (08:00 UTC); still open at day 4 → escalation flag</a:t>
             </a:r>
             <a:endParaRPr lang="en-US" sz="1050" dirty="0"/>
           </a:p>
@@ -6587,7 +6587,7 @@
                   <a:srgbClr val="1A2433"/>
                 </a:solidFill>
               </a:rPr>
-              <a:t>Scan history, durations, counts → History page; alarms on failures</a:t>
+              <a:t>Scan history, durations, added/changed/removed counts → Scan operations page</a:t>
             </a:r>
             <a:endParaRPr lang="en-US" sz="1050" dirty="0"/>
           </a:p>
@@ -6721,7 +6721,7 @@
                 <a:ea typeface="Arial" pitchFamily="34" charset="-122"/>
                 <a:cs typeface="Arial" pitchFamily="34" charset="-120"/>
               </a:rPr>
-              <a:t>Launch: same-account mode (local read-only role, no AssumeRole). Growth: deploy one CloudFormation stack per new account, register it with its scan-region list (default us-east-1). Access-key auth is deliberately not supported.</a:t>
+              <a:t>Same-account mode: CloudPulse scans its own account with its own read-only roles. Growth: deploy one CloudFormation stack per new account and register it with its scan regions. Access keys are deliberately not supported.</a:t>
             </a:r>
             <a:endParaRPr lang="en-US" sz="1200" dirty="0"/>
           </a:p>
@@ -6919,7 +6919,7 @@
                 <a:ea typeface="Arial" pitchFamily="34" charset="-122"/>
                 <a:cs typeface="Arial" pitchFamily="34" charset="-120"/>
               </a:rPr>
-              <a:t>Scan / remediation</a:t>
+              <a:t>Scan and worker</a:t>
             </a:r>
             <a:endParaRPr lang="en-US" sz="850" dirty="0"/>
           </a:p>
@@ -7025,7 +7025,7 @@
                 <a:ea typeface="Arial" pitchFamily="34" charset="-122"/>
                 <a:cs typeface="Arial" pitchFamily="34" charset="-120"/>
               </a:rPr>
-              <a:t>(scoped to CloudPulse* roles)</a:t>
+              <a:t>(scoped to cloudpulse-scanner)</a:t>
             </a:r>
             <a:endParaRPr lang="en-US" sz="850" dirty="0"/>
           </a:p>
@@ -7082,7 +7082,7 @@
                   <a:srgbClr val="1A2433"/>
                 </a:solidFill>
               </a:rPr>
-              <a:t>Per-tenant ExternalId (confused-deputy guard)</a:t>
+              <a:t>Platform-generated ExternalId per account (confused-deputy guard)</a:t>
             </a:r>
             <a:endParaRPr lang="en-US" sz="1100" dirty="0"/>
           </a:p>
@@ -7100,7 +7100,7 @@
                   <a:srgbClr val="1A2433"/>
                 </a:solidFill>
               </a:rPr>
-              <a:t>Read-only scanner: SecurityAudit + ViewOnlyAccess + tag:GetResources</a:t>
+              <a:t>Read-only scanner: an explicit Describe/Get/List list, checked by a unit test</a:t>
             </a:r>
             <a:endParaRPr lang="en-US" sz="1100" dirty="0"/>
           </a:p>
@@ -7118,7 +7118,7 @@
                   <a:srgbClr val="1A2433"/>
                 </a:solidFill>
               </a:rPr>
-              <a:t>Separate CloudPulseRemediatorRole (R2), tag-write only, opt-in per account</a:t>
+              <a:t>No write role exists: remediation is out of scope by design</a:t>
             </a:r>
             <a:endParaRPr lang="en-US" sz="1100" dirty="0"/>
           </a:p>
@@ -7136,7 +7136,7 @@
                   <a:srgbClr val="1A2433"/>
                 </a:solidFill>
               </a:rPr>
-              <a:t>Sessions 15 min, all calls in spoke CloudTrail</a:t>
+              <a:t>Sessions 15 min, all calls in the target account's CloudTrail</a:t>
             </a:r>
             <a:endParaRPr lang="en-US" sz="1100" dirty="0"/>
           </a:p>
@@ -7288,7 +7288,7 @@
                 <a:ea typeface="Arial" pitchFamily="34" charset="-122"/>
                 <a:cs typeface="Arial" pitchFamily="34" charset="-120"/>
               </a:rPr>
-              <a:t>Launch account — CloudPulse hub deploys INSIDE it</a:t>
+              <a:t>Same account — CloudPulse runs INSIDE it</a:t>
             </a:r>
             <a:endParaRPr lang="en-US" sz="1100" dirty="0"/>
           </a:p>
@@ -7348,7 +7348,7 @@
                   <a:srgbClr val="1A2433"/>
                 </a:solidFill>
               </a:rPr>
-              <a:t>Local read-only role (no AssumeRole)</a:t>
+              <a:t>Own read-only roles (no AssumeRole)</a:t>
             </a:r>
             <a:endParaRPr lang="en-US" sz="900" dirty="0"/>
           </a:p>
@@ -7546,7 +7546,7 @@
                   <a:srgbClr val="1A2433"/>
                 </a:solidFill>
               </a:rPr>
-              <a:t>CloudPulseScannerRole</a:t>
+              <a:t>cloudpulse-scanner</a:t>
             </a:r>
             <a:endParaRPr lang="en-US" sz="900" dirty="0"/>
           </a:p>
@@ -7744,7 +7744,7 @@
                   <a:srgbClr val="1A2433"/>
                 </a:solidFill>
               </a:rPr>
-              <a:t>CloudPulseScannerRole</a:t>
+              <a:t>cloudpulse-scanner</a:t>
             </a:r>
             <a:endParaRPr lang="en-US" sz="900" dirty="0"/>
           </a:p>
@@ -7923,7 +7923,7 @@
                 <a:ea typeface="Arial" pitchFamily="34" charset="-122"/>
                 <a:cs typeface="Arial" pitchFamily="34" charset="-120"/>
               </a:rPr>
-              <a:t>Cost Governance &amp; GenAI Layer (Release 2–3)</a:t>
+              <a:t>Cost Governance &amp; AI Layer</a:t>
             </a:r>
             <a:endParaRPr lang="en-US" sz="2600" dirty="0"/>
           </a:p>
@@ -7962,7 +7962,7 @@
                 <a:ea typeface="Arial" pitchFamily="34" charset="-122"/>
                 <a:cs typeface="Arial" pitchFamily="34" charset="-120"/>
               </a:rPr>
-              <a:t>Cost signals come from native AWS services; Bedrock explains and recommends — it never holds credentials or executes changes.</a:t>
+              <a:t>Cost signals come from native AWS services; the AI explains and recommends — it never holds credentials or executes changes.</a:t>
             </a:r>
             <a:endParaRPr lang="en-US" sz="1200" dirty="0"/>
           </a:p>
@@ -8089,7 +8089,7 @@
                 <a:ea typeface="Arial" pitchFamily="34" charset="-122"/>
                 <a:cs typeface="Arial" pitchFamily="34" charset="-120"/>
               </a:rPr>
-              <a:t>R2</a:t>
+              <a:t>P1/P2</a:t>
             </a:r>
             <a:endParaRPr lang="en-US" sz="900" dirty="0"/>
           </a:p>
@@ -8175,7 +8175,7 @@
                 <a:ea typeface="Arial" pitchFamily="34" charset="-122"/>
                 <a:cs typeface="Arial" pitchFamily="34" charset="-120"/>
               </a:rPr>
-              <a:t>spend by project tag</a:t>
+              <a:t>daily spend per account</a:t>
             </a:r>
             <a:endParaRPr lang="en-US" sz="850" dirty="0"/>
           </a:p>
@@ -8241,7 +8241,7 @@
                 <a:ea typeface="Arial" pitchFamily="34" charset="-122"/>
                 <a:cs typeface="Arial" pitchFamily="34" charset="-120"/>
               </a:rPr>
-              <a:t>AWS Budgets</a:t>
+              <a:t>Budgets per SDA</a:t>
             </a:r>
             <a:endParaRPr lang="en-US" sz="850" dirty="0"/>
           </a:p>
@@ -8261,7 +8261,7 @@
                 <a:ea typeface="Arial" pitchFamily="34" charset="-122"/>
                 <a:cs typeface="Arial" pitchFamily="34" charset="-120"/>
               </a:rPr>
-              <a:t>auto-created per project</a:t>
+              <a:t>auto-created in CloudPulse</a:t>
             </a:r>
             <a:endParaRPr lang="en-US" sz="850" dirty="0"/>
           </a:p>
@@ -8281,7 +8281,7 @@
                 <a:ea typeface="Arial" pitchFamily="34" charset="-122"/>
                 <a:cs typeface="Arial" pitchFamily="34" charset="-120"/>
               </a:rPr>
-              <a:t>80% / 100% alerts</a:t>
+              <a:t>overrun → finding</a:t>
             </a:r>
             <a:endParaRPr lang="en-US" sz="850" dirty="0"/>
           </a:p>
@@ -8347,7 +8347,7 @@
                 <a:ea typeface="Arial" pitchFamily="34" charset="-122"/>
                 <a:cs typeface="Arial" pitchFamily="34" charset="-120"/>
               </a:rPr>
-              <a:t>Compute Optimizer</a:t>
+              <a:t>CloudWatch metrics</a:t>
             </a:r>
             <a:endParaRPr lang="en-US" sz="850" dirty="0"/>
           </a:p>
@@ -8367,7 +8367,7 @@
                 <a:ea typeface="Arial" pitchFamily="34" charset="-122"/>
                 <a:cs typeface="Arial" pitchFamily="34" charset="-120"/>
               </a:rPr>
-              <a:t>rightsizing signals</a:t>
+              <a:t>rightsizing evidence</a:t>
             </a:r>
             <a:endParaRPr lang="en-US" sz="850" dirty="0"/>
           </a:p>
@@ -8410,7 +8410,7 @@
                   <a:srgbClr val="1A2433"/>
                 </a:solidFill>
               </a:rPr>
-              <a:t>Overrun detection: forecast + actual vs project budget → findings pipeline (same lifecycle as tag findings)</a:t>
+              <a:t>Overrun detection: actual spend vs SDA budget → findings pipeline (same lifecycle as tag findings)</a:t>
             </a:r>
             <a:endParaRPr lang="en-US" sz="1100" dirty="0"/>
           </a:p>
@@ -8431,7 +8431,7 @@
                   <a:srgbClr val="1A2433"/>
                 </a:solidFill>
               </a:rPr>
-              <a:t>Unused resources: idle EC2, unattached EBS, orphaned EIPs, idle RDS → savings estimates</a:t>
+              <a:t>Utilization: active vs idle from resource state; IAM hygiene flags unused principals weekly</a:t>
             </a:r>
             <a:endParaRPr lang="en-US" sz="1100" dirty="0"/>
           </a:p>
@@ -8452,7 +8452,7 @@
                   <a:srgbClr val="1A2433"/>
                 </a:solidFill>
               </a:rPr>
-              <a:t>Cost dashboard: spend by project / SDA / environment with drill-down; sandbox utilization % (R3)</a:t>
+              <a:t>Cost dashboard: daily spend by account and SDA; forecasts with their backtest error</a:t>
             </a:r>
             <a:endParaRPr lang="en-US" sz="1100" dirty="0"/>
           </a:p>
@@ -8473,7 +8473,7 @@
                   <a:srgbClr val="1A2433"/>
                 </a:solidFill>
               </a:rPr>
-              <a:t>Recommendations: shutdown, cleanup, rightsize (m5.2xlarge → m5.xlarge), reserved capacity</a:t>
+              <a:t>Rightsizing: low and steady CPU → one size down, with evidence and an estimated saving</a:t>
             </a:r>
             <a:endParaRPr lang="en-US" sz="1100" dirty="0"/>
           </a:p>
@@ -8539,7 +8539,7 @@
                 <a:ea typeface="Arial" pitchFamily="34" charset="-122"/>
                 <a:cs typeface="Arial" pitchFamily="34" charset="-120"/>
               </a:rPr>
-              <a:t>GenAI on Amazon Bedrock (Claude)</a:t>
+              <a:t>AI on Bedrock AgentCore + Nova 2 Lite</a:t>
             </a:r>
             <a:endParaRPr lang="en-US" sz="1100" dirty="0"/>
           </a:p>
@@ -8600,7 +8600,7 @@
                 <a:ea typeface="Arial" pitchFamily="34" charset="-122"/>
                 <a:cs typeface="Arial" pitchFamily="34" charset="-120"/>
               </a:rPr>
-              <a:t>R2+</a:t>
+              <a:t>P1/P2</a:t>
             </a:r>
             <a:endParaRPr lang="en-US" sz="900" dirty="0"/>
           </a:p>
@@ -8666,7 +8666,7 @@
                 <a:ea typeface="Arial" pitchFamily="34" charset="-122"/>
                 <a:cs typeface="Arial" pitchFamily="34" charset="-120"/>
               </a:rPr>
-              <a:t>Bedrock</a:t>
+              <a:t>AgentCore Runtime</a:t>
             </a:r>
             <a:endParaRPr lang="en-US" sz="850" dirty="0"/>
           </a:p>
@@ -8686,7 +8686,7 @@
                 <a:ea typeface="Arial" pitchFamily="34" charset="-122"/>
                 <a:cs typeface="Arial" pitchFamily="34" charset="-120"/>
               </a:rPr>
-              <a:t>Converse API</a:t>
+              <a:t>Converse tool loop</a:t>
             </a:r>
             <a:endParaRPr lang="en-US" sz="850" dirty="0"/>
           </a:p>
@@ -8752,7 +8752,7 @@
                 <a:ea typeface="Arial" pitchFamily="34" charset="-122"/>
                 <a:cs typeface="Arial" pitchFamily="34" charset="-120"/>
               </a:rPr>
-              <a:t>Insight jobs</a:t>
+              <a:t>Daily workers</a:t>
             </a:r>
             <a:endParaRPr lang="en-US" sz="850" dirty="0"/>
           </a:p>
@@ -8772,7 +8772,7 @@
                 <a:ea typeface="Arial" pitchFamily="34" charset="-122"/>
                 <a:cs typeface="Arial" pitchFamily="34" charset="-120"/>
               </a:rPr>
-              <a:t>(nightly digest)</a:t>
+              <a:t>(digest, suggester)</a:t>
             </a:r>
             <a:endParaRPr lang="en-US" sz="850" dirty="0"/>
           </a:p>
@@ -8858,7 +8858,7 @@
                 <a:ea typeface="Arial" pitchFamily="34" charset="-122"/>
                 <a:cs typeface="Arial" pitchFamily="34" charset="-120"/>
               </a:rPr>
-              <a:t>for NL Q&amp;A (R3)</a:t>
+              <a:t>allowlisted GETs only</a:t>
             </a:r>
             <a:endParaRPr lang="en-US" sz="850" dirty="0"/>
           </a:p>
@@ -8901,7 +8901,7 @@
                   <a:srgbClr val="1A2433"/>
                 </a:solidFill>
               </a:rPr>
-              <a:t>Findings digest: nightly summary of top findings + cost deltas → dashboard card + weekly email</a:t>
+              <a:t>Insight digest: daily summary of top findings + spend → overview card, grounded before display</a:t>
             </a:r>
             <a:endParaRPr lang="en-US" sz="1100" dirty="0"/>
           </a:p>
@@ -8922,7 +8922,7 @@
                   <a:srgbClr val="1A2433"/>
                 </a:solidFill>
               </a:rPr>
-              <a:t>Remediation suggester: drafts action + blast-radius note per finding class; human approves</a:t>
+              <a:t>Remediation suggester: one suggestion + blast-radius note per finding; people act on it</a:t>
             </a:r>
             <a:endParaRPr lang="en-US" sz="1100" dirty="0"/>
           </a:p>
@@ -8943,7 +8943,7 @@
                   <a:srgbClr val="1A2433"/>
                 </a:solidFill>
               </a:rPr>
-              <a:t>NL Q&amp;A (R3): “Which untagged prod resources cost most last month?” — tool-use against CloudPulse API, tenant-scoped, answers cite ARNs</a:t>
+              <a:t>Grounding gate: deterministic code rejects any invented ARN or figure; rejections are recorded, never shown</a:t>
             </a:r>
             <a:endParaRPr lang="en-US" sz="1100" dirty="0"/>
           </a:p>
@@ -8964,7 +8964,7 @@
                   <a:srgbClr val="1A2433"/>
                 </a:solidFill>
               </a:rPr>
-              <a:t>Cost control: Haiku for classification, Sonnet for digests; cached outputs; Bedrock budget alarm</a:t>
+              <a:t>Cost control: per-run token cap; item-wise outputs keep validated items; Guardrail on every call</a:t>
             </a:r>
             <a:endParaRPr lang="en-US" sz="1100" dirty="0"/>
           </a:p>
@@ -9074,7 +9074,7 @@
                 <a:ea typeface="Arial" pitchFamily="34" charset="-122"/>
                 <a:cs typeface="Arial" pitchFamily="34" charset="-120"/>
               </a:rPr>
-              <a:t>Monorepo: /infra (Terraform), /backend (FastAPI + workers), /frontend (Angular), /connectors. Trunk-based; deploy on merge to main.</a:t>
+              <a:t>Monorepo: /infra (Terraform), /backend (FastAPI + workers), /frontend (Angular), /agents, /specs. Trunk-based on pods/pod73.</a:t>
             </a:r>
             <a:endParaRPr lang="en-US" sz="1200" dirty="0"/>
           </a:p>
@@ -9137,7 +9137,7 @@
                   <a:srgbClr val="232F3E"/>
                 </a:solidFill>
               </a:rPr>
-              <a:t>Push / PR</a:t>
+              <a:t>Pull request</a:t>
             </a:r>
             <a:endParaRPr lang="en-US" sz="1300" dirty="0"/>
           </a:p>
@@ -9176,7 +9176,7 @@
                   <a:srgbClr val="1A2433"/>
                 </a:solidFill>
               </a:rPr>
-              <a:t>Lint • mypy • unit tests (moto) • Angular build • tf validate &amp; plan</a:t>
+              <a:t>16 required checks: lint • types • unit • integration • e2e • tf • contract • evals • AI review</a:t>
             </a:r>
             <a:endParaRPr lang="en-US" sz="1000" dirty="0"/>
           </a:p>
@@ -9263,7 +9263,7 @@
                   <a:srgbClr val="232F3E"/>
                 </a:solidFill>
               </a:rPr>
-              <a:t>Merge to main</a:t>
+              <a:t>Merge to pods/pod73</a:t>
             </a:r>
             <a:endParaRPr lang="en-US" sz="1300" dirty="0"/>
           </a:p>
@@ -9302,7 +9302,7 @@
                   <a:srgbClr val="1A2433"/>
                 </a:solidFill>
               </a:rPr>
-              <a:t>Integration tests (LocalStack) • package Lambdas • build SPA</a:t>
+              <a:t>Trunk stays green; automatic dev deploy is off (DEV_AUTO_DEPLOY=false)</a:t>
             </a:r>
             <a:endParaRPr lang="en-US" sz="1000" dirty="0"/>
           </a:p>
@@ -9389,7 +9389,7 @@
                   <a:srgbClr val="232F3E"/>
                 </a:solidFill>
               </a:rPr>
-              <a:t>Deploy dev</a:t>
+              <a:t>Deploy dev (manual)</a:t>
             </a:r>
             <a:endParaRPr lang="en-US" sz="1300" dirty="0"/>
           </a:p>
@@ -9428,7 +9428,7 @@
                   <a:srgbClr val="1A2433"/>
                 </a:solidFill>
               </a:rPr>
-              <a:t>terraform apply (auto) • Alembic migrations • smoke tests</a:t>
+              <a:t>build • terraform apply (optional NAT egress) • migrations • health + Playwright smoke</a:t>
             </a:r>
             <a:endParaRPr lang="en-US" sz="1000" dirty="0"/>
           </a:p>
@@ -9515,7 +9515,7 @@
                   <a:srgbClr val="232F3E"/>
                 </a:solidFill>
               </a:rPr>
-              <a:t>Deploy prod</a:t>
+              <a:t>Teardown</a:t>
             </a:r>
             <a:endParaRPr lang="en-US" sz="1300" dirty="0"/>
           </a:p>
@@ -9554,7 +9554,7 @@
                   <a:srgbClr val="1A2433"/>
                 </a:solidFill>
               </a:rPr>
-              <a:t>Manual approval gate • apply • CloudFront invalidation • canary alarm watch</a:t>
+              <a:t>ops/teardown.sh dev • sweep against the pre-deploy baseline • zero cost</a:t>
             </a:r>
             <a:endParaRPr lang="en-US" sz="1000" dirty="0"/>
           </a:p>
@@ -9620,7 +9620,7 @@
                 <a:ea typeface="Arial" pitchFamily="34" charset="-122"/>
                 <a:cs typeface="Arial" pitchFamily="34" charset="-120"/>
               </a:rPr>
-              <a:t>dev environment (hub account: cloudpulse-dev)</a:t>
+              <a:t>dev — the one environment, deployed per working session</a:t>
             </a:r>
             <a:endParaRPr lang="en-US" sz="1100" dirty="0"/>
           </a:p>
@@ -9686,7 +9686,7 @@
                 <a:ea typeface="Arial" pitchFamily="34" charset="-122"/>
                 <a:cs typeface="Arial" pitchFamily="34" charset="-120"/>
               </a:rPr>
-              <a:t>prod environment (hub account: cloudpulse-prod)</a:t>
+              <a:t>prod root module — kept in the repo, unused by decision</a:t>
             </a:r>
             <a:endParaRPr lang="en-US" sz="1100" dirty="0"/>
           </a:p>
@@ -10086,7 +10086,7 @@
                   <a:srgbClr val="1A2433"/>
                 </a:solidFill>
               </a:rPr>
-              <a:t>Separate hub accounts for dev and prod; spokes onboard to prod only</a:t>
+              <a:t>One environment by decision: dev is deployed for a session, then torn down</a:t>
             </a:r>
             <a:endParaRPr lang="en-US" sz="1050" dirty="0"/>
           </a:p>
@@ -10104,7 +10104,7 @@
                   <a:srgbClr val="1A2433"/>
                 </a:solidFill>
               </a:rPr>
-              <a:t>GitHub OIDC federation → short-lived deploy roles per environment</a:t>
+              <a:t>GitHub OIDC federation → short-lived deploy role, no stored keys</a:t>
             </a:r>
             <a:endParaRPr lang="en-US" sz="1050" dirty="0"/>
           </a:p>
@@ -10122,7 +10122,7 @@
                   <a:srgbClr val="1A2433"/>
                 </a:solidFill>
               </a:rPr>
-              <a:t>Terraform state in S3 + DynamoDB lock, one state per env</a:t>
+              <a:t>Terraform state in S3 + DynamoDB lock</a:t>
             </a:r>
             <a:endParaRPr lang="en-US" sz="1050" dirty="0"/>
           </a:p>
@@ -10162,7 +10162,7 @@
                   <a:srgbClr val="1A2433"/>
                 </a:solidFill>
               </a:rPr>
-              <a:t>Rollback: Lambda aliases + previous artifact re-deploy; DB via expand-contract migrations</a:t>
+              <a:t>Rollback: redeploy the previous commit; migrations are additive-only</a:t>
             </a:r>
             <a:endParaRPr lang="en-US" sz="1050" dirty="0"/>
           </a:p>
@@ -10180,7 +10180,7 @@
                   <a:srgbClr val="1A2433"/>
                 </a:solidFill>
               </a:rPr>
-              <a:t>Observability: CloudWatch dashboards + alarms → SNS → email/Slack</a:t>
+              <a:t>Observability: structured logs + correlation IDs; dashboards and alarms are optional (P2, off)</a:t>
             </a:r>
             <a:endParaRPr lang="en-US" sz="1050" dirty="0"/>
           </a:p>
@@ -10198,7 +10198,7 @@
                   <a:srgbClr val="1A2433"/>
                 </a:solidFill>
               </a:rPr>
-              <a:t>Full pipeline YAML and runbooks in the Engineering Guide (docx)</a:t>
+              <a:t>Full pipeline, provisioning and teardown in the Engineering Guide and README</a:t>
             </a:r>
             <a:endParaRPr lang="en-US" sz="1050" dirty="0"/>
           </a:p>

</xml_diff>